<commit_message>
Update PPTX: Kimi K2.5 default, correct API URL, updated model IDs
- Default model: moonshotai/Kimi-K2.5
- Llama: meta-llama/Llama-3.3-70B-Instruct-fast
- DeepSeek: deepseek-ai/DeepSeek-R1-0528
- API URL: https://api.tokenfactory.nebius.com/v1/ (trailing slash)
- Added Token Factory cookbook repo to resources

Co-Authored-By: Claude Opus 4.6 (1M context) <noreply@anthropic.com>
</commit_message>
<xml_diff>
--- a/workshops/running-openclaw-on-nebius.pptx
+++ b/workshops/running-openclaw-on-nebius.pptx
@@ -3229,7 +3229,7 @@
                 <a:ea typeface="Courier New" pitchFamily="34" charset="-122"/>
                 <a:cs typeface="Courier New" pitchFamily="34" charset="-120"/>
               </a:rPr>
-              <a:t>/models          # List all models</a:t>
+              <a:t>/models        # List all models</a:t>
             </a:r>
             <a:endParaRPr lang="en-US" sz="1000" dirty="0"/>
           </a:p>
@@ -3252,7 +3252,7 @@
                 <a:ea typeface="Courier New" pitchFamily="34" charset="-122"/>
                 <a:cs typeface="Courier New" pitchFamily="34" charset="-120"/>
               </a:rPr>
-              <a:t>/model llama70b  # Switch model</a:t>
+              <a:t>/model kimi    # Switch to Kimi K2.5</a:t>
             </a:r>
             <a:endParaRPr lang="en-US" sz="1000" dirty="0"/>
           </a:p>
@@ -3275,7 +3275,7 @@
                 <a:ea typeface="Courier New" pitchFamily="34" charset="-122"/>
                 <a:cs typeface="Courier New" pitchFamily="34" charset="-120"/>
               </a:rPr>
-              <a:t>/status          # Check connection</a:t>
+              <a:t>/status        # Check connection</a:t>
             </a:r>
             <a:endParaRPr lang="en-US" sz="1000" dirty="0"/>
           </a:p>
@@ -3314,7 +3314,7 @@
                 <a:ea typeface="Arial" pitchFamily="34" charset="-122"/>
                 <a:cs typeface="Arial" pitchFamily="34" charset="-120"/>
               </a:rPr>
-              <a:t>Your agent is live. No GPU on your machine.</a:t>
+              <a:t>Your agent is live. Connected to Kimi K2.5 on Nebius.</a:t>
             </a:r>
             <a:endParaRPr lang="en-US" sz="1400" dirty="0"/>
           </a:p>
@@ -3603,7 +3603,7 @@
                           <a:ea typeface="Arial" pitchFamily="34" charset="-122"/>
                           <a:cs typeface="Arial" pitchFamily="34" charset="-120"/>
                         </a:rPr>
-                        <a:t>Speed</a:t>
+                        <a:t>ID</a:t>
                       </a:r>
                       <a:endParaRPr lang="en-US" sz="1000" dirty="0">
                         <a:latin typeface="Arial" charset="0"/>
@@ -3671,7 +3671,7 @@
                           <a:ea typeface="Arial" pitchFamily="34" charset="-122"/>
                           <a:cs typeface="Arial" pitchFamily="34" charset="-120"/>
                         </a:rPr>
-                        <a:t>Quality</a:t>
+                        <a:t>Speed</a:t>
                       </a:r>
                       <a:endParaRPr lang="en-US" sz="1000" dirty="0">
                         <a:latin typeface="Arial" charset="0"/>
@@ -3809,7 +3809,75 @@
                           <a:ea typeface="Arial" pitchFamily="34" charset="-122"/>
                           <a:cs typeface="Arial" pitchFamily="34" charset="-120"/>
                         </a:rPr>
-                        <a:t>Llama 3.1 70B</a:t>
+                        <a:t>Kimi K2.5</a:t>
+                      </a:r>
+                      <a:endParaRPr lang="en-US" sz="900" dirty="0">
+                        <a:latin typeface="Arial" charset="0"/>
+                        <a:ea typeface="Arial" charset="0"/>
+                        <a:cs typeface="Arial" charset="0"/>
+                      </a:endParaRPr>
+                    </a:p>
+                  </a:txBody>
+                  <a:tcPr marL="91440" marR="91440" marT="45720" marB="45720">
+                    <a:lnL w="6350" cap="flat" cmpd="sng" algn="ctr">
+                      <a:solidFill>
+                        <a:srgbClr val="2A2D3E"/>
+                      </a:solidFill>
+                      <a:prstDash val="solid"/>
+                      <a:round/>
+                      <a:headEnd type="none" w="med" len="med"/>
+                      <a:tailEnd type="none" w="med" len="med"/>
+                    </a:lnL>
+                    <a:lnR w="6350" cap="flat" cmpd="sng" algn="ctr">
+                      <a:solidFill>
+                        <a:srgbClr val="2A2D3E"/>
+                      </a:solidFill>
+                      <a:prstDash val="solid"/>
+                      <a:round/>
+                      <a:headEnd type="none" w="med" len="med"/>
+                      <a:tailEnd type="none" w="med" len="med"/>
+                    </a:lnR>
+                    <a:lnT w="6350" cap="flat" cmpd="sng" algn="ctr">
+                      <a:solidFill>
+                        <a:srgbClr val="2A2D3E"/>
+                      </a:solidFill>
+                      <a:prstDash val="solid"/>
+                      <a:round/>
+                      <a:headEnd type="none" w="med" len="med"/>
+                      <a:tailEnd type="none" w="med" len="med"/>
+                    </a:lnT>
+                    <a:lnB w="6350" cap="flat" cmpd="sng" algn="ctr">
+                      <a:solidFill>
+                        <a:srgbClr val="2A2D3E"/>
+                      </a:solidFill>
+                      <a:prstDash val="solid"/>
+                      <a:round/>
+                      <a:headEnd type="none" w="med" len="med"/>
+                      <a:tailEnd type="none" w="med" len="med"/>
+                    </a:lnB>
+                    <a:solidFill>
+                      <a:srgbClr val="1A1D2E"/>
+                    </a:solidFill>
+                  </a:tcPr>
+                </a:tc>
+                <a:tc>
+                  <a:txBody>
+                    <a:bodyPr/>
+                    <a:lstStyle/>
+                    <a:p>
+                      <a:pPr indent="0" marL="0">
+                        <a:buNone/>
+                      </a:pPr>
+                      <a:r>
+                        <a:rPr lang="en-US" sz="900" dirty="0">
+                          <a:solidFill>
+                            <a:srgbClr val="FFFFFF"/>
+                          </a:solidFill>
+                          <a:latin typeface="Arial" pitchFamily="34" charset="0"/>
+                          <a:ea typeface="Arial" pitchFamily="34" charset="-122"/>
+                          <a:cs typeface="Arial" pitchFamily="34" charset="-120"/>
+                        </a:rPr>
+                        <a:t>moonshotai/Kimi-K2.5</a:t>
                       </a:r>
                       <a:endParaRPr lang="en-US" sz="900" dirty="0">
                         <a:latin typeface="Arial" charset="0"/>
@@ -3945,7 +4013,77 @@
                           <a:ea typeface="Arial" pitchFamily="34" charset="-122"/>
                           <a:cs typeface="Arial" pitchFamily="34" charset="-120"/>
                         </a:rPr>
-                        <a:t>High</a:t>
+                        <a:t>Recommended all-rounder</a:t>
+                      </a:r>
+                      <a:endParaRPr lang="en-US" sz="900" dirty="0">
+                        <a:latin typeface="Arial" charset="0"/>
+                        <a:ea typeface="Arial" charset="0"/>
+                        <a:cs typeface="Arial" charset="0"/>
+                      </a:endParaRPr>
+                    </a:p>
+                  </a:txBody>
+                  <a:tcPr marL="91440" marR="91440" marT="45720" marB="45720">
+                    <a:lnL w="6350" cap="flat" cmpd="sng" algn="ctr">
+                      <a:solidFill>
+                        <a:srgbClr val="2A2D3E"/>
+                      </a:solidFill>
+                      <a:prstDash val="solid"/>
+                      <a:round/>
+                      <a:headEnd type="none" w="med" len="med"/>
+                      <a:tailEnd type="none" w="med" len="med"/>
+                    </a:lnL>
+                    <a:lnR w="6350" cap="flat" cmpd="sng" algn="ctr">
+                      <a:solidFill>
+                        <a:srgbClr val="2A2D3E"/>
+                      </a:solidFill>
+                      <a:prstDash val="solid"/>
+                      <a:round/>
+                      <a:headEnd type="none" w="med" len="med"/>
+                      <a:tailEnd type="none" w="med" len="med"/>
+                    </a:lnR>
+                    <a:lnT w="6350" cap="flat" cmpd="sng" algn="ctr">
+                      <a:solidFill>
+                        <a:srgbClr val="2A2D3E"/>
+                      </a:solidFill>
+                      <a:prstDash val="solid"/>
+                      <a:round/>
+                      <a:headEnd type="none" w="med" len="med"/>
+                      <a:tailEnd type="none" w="med" len="med"/>
+                    </a:lnT>
+                    <a:lnB w="6350" cap="flat" cmpd="sng" algn="ctr">
+                      <a:solidFill>
+                        <a:srgbClr val="2A2D3E"/>
+                      </a:solidFill>
+                      <a:prstDash val="solid"/>
+                      <a:round/>
+                      <a:headEnd type="none" w="med" len="med"/>
+                      <a:tailEnd type="none" w="med" len="med"/>
+                    </a:lnB>
+                    <a:solidFill>
+                      <a:srgbClr val="1A1D2E"/>
+                    </a:solidFill>
+                  </a:tcPr>
+                </a:tc>
+              </a:tr>
+              <a:tr h="320040">
+                <a:tc>
+                  <a:txBody>
+                    <a:bodyPr/>
+                    <a:lstStyle/>
+                    <a:p>
+                      <a:pPr indent="0" marL="0">
+                        <a:buNone/>
+                      </a:pPr>
+                      <a:r>
+                        <a:rPr lang="en-US" sz="900" dirty="0">
+                          <a:solidFill>
+                            <a:srgbClr val="FFFFFF"/>
+                          </a:solidFill>
+                          <a:latin typeface="Arial" pitchFamily="34" charset="0"/>
+                          <a:ea typeface="Arial" pitchFamily="34" charset="-122"/>
+                          <a:cs typeface="Arial" pitchFamily="34" charset="-120"/>
+                        </a:rPr>
+                        <a:t>Llama 3.3 70B</a:t>
                       </a:r>
                       <a:endParaRPr lang="en-US" sz="900" dirty="0">
                         <a:latin typeface="Arial" charset="0"/>
@@ -4013,7 +4151,417 @@
                           <a:ea typeface="Arial" pitchFamily="34" charset="-122"/>
                           <a:cs typeface="Arial" pitchFamily="34" charset="-120"/>
                         </a:rPr>
-                        <a:t>General agents, tool calling</a:t>
+                        <a:t>meta-llama/Llama-3.3-70B-Instruct-fast</a:t>
+                      </a:r>
+                      <a:endParaRPr lang="en-US" sz="900" dirty="0">
+                        <a:latin typeface="Arial" charset="0"/>
+                        <a:ea typeface="Arial" charset="0"/>
+                        <a:cs typeface="Arial" charset="0"/>
+                      </a:endParaRPr>
+                    </a:p>
+                  </a:txBody>
+                  <a:tcPr marL="91440" marR="91440" marT="45720" marB="45720">
+                    <a:lnL w="6350" cap="flat" cmpd="sng" algn="ctr">
+                      <a:solidFill>
+                        <a:srgbClr val="2A2D3E"/>
+                      </a:solidFill>
+                      <a:prstDash val="solid"/>
+                      <a:round/>
+                      <a:headEnd type="none" w="med" len="med"/>
+                      <a:tailEnd type="none" w="med" len="med"/>
+                    </a:lnL>
+                    <a:lnR w="6350" cap="flat" cmpd="sng" algn="ctr">
+                      <a:solidFill>
+                        <a:srgbClr val="2A2D3E"/>
+                      </a:solidFill>
+                      <a:prstDash val="solid"/>
+                      <a:round/>
+                      <a:headEnd type="none" w="med" len="med"/>
+                      <a:tailEnd type="none" w="med" len="med"/>
+                    </a:lnR>
+                    <a:lnT w="6350" cap="flat" cmpd="sng" algn="ctr">
+                      <a:solidFill>
+                        <a:srgbClr val="2A2D3E"/>
+                      </a:solidFill>
+                      <a:prstDash val="solid"/>
+                      <a:round/>
+                      <a:headEnd type="none" w="med" len="med"/>
+                      <a:tailEnd type="none" w="med" len="med"/>
+                    </a:lnT>
+                    <a:lnB w="6350" cap="flat" cmpd="sng" algn="ctr">
+                      <a:solidFill>
+                        <a:srgbClr val="2A2D3E"/>
+                      </a:solidFill>
+                      <a:prstDash val="solid"/>
+                      <a:round/>
+                      <a:headEnd type="none" w="med" len="med"/>
+                      <a:tailEnd type="none" w="med" len="med"/>
+                    </a:lnB>
+                    <a:solidFill>
+                      <a:srgbClr val="1A1D2E"/>
+                    </a:solidFill>
+                  </a:tcPr>
+                </a:tc>
+                <a:tc>
+                  <a:txBody>
+                    <a:bodyPr/>
+                    <a:lstStyle/>
+                    <a:p>
+                      <a:pPr indent="0" marL="0">
+                        <a:buNone/>
+                      </a:pPr>
+                      <a:r>
+                        <a:rPr lang="en-US" sz="900" dirty="0">
+                          <a:solidFill>
+                            <a:srgbClr val="FFFFFF"/>
+                          </a:solidFill>
+                          <a:latin typeface="Arial" pitchFamily="34" charset="0"/>
+                          <a:ea typeface="Arial" pitchFamily="34" charset="-122"/>
+                          <a:cs typeface="Arial" pitchFamily="34" charset="-120"/>
+                        </a:rPr>
+                        <a:t>Fast</a:t>
+                      </a:r>
+                      <a:endParaRPr lang="en-US" sz="900" dirty="0">
+                        <a:latin typeface="Arial" charset="0"/>
+                        <a:ea typeface="Arial" charset="0"/>
+                        <a:cs typeface="Arial" charset="0"/>
+                      </a:endParaRPr>
+                    </a:p>
+                  </a:txBody>
+                  <a:tcPr marL="91440" marR="91440" marT="45720" marB="45720">
+                    <a:lnL w="6350" cap="flat" cmpd="sng" algn="ctr">
+                      <a:solidFill>
+                        <a:srgbClr val="2A2D3E"/>
+                      </a:solidFill>
+                      <a:prstDash val="solid"/>
+                      <a:round/>
+                      <a:headEnd type="none" w="med" len="med"/>
+                      <a:tailEnd type="none" w="med" len="med"/>
+                    </a:lnL>
+                    <a:lnR w="6350" cap="flat" cmpd="sng" algn="ctr">
+                      <a:solidFill>
+                        <a:srgbClr val="2A2D3E"/>
+                      </a:solidFill>
+                      <a:prstDash val="solid"/>
+                      <a:round/>
+                      <a:headEnd type="none" w="med" len="med"/>
+                      <a:tailEnd type="none" w="med" len="med"/>
+                    </a:lnR>
+                    <a:lnT w="6350" cap="flat" cmpd="sng" algn="ctr">
+                      <a:solidFill>
+                        <a:srgbClr val="2A2D3E"/>
+                      </a:solidFill>
+                      <a:prstDash val="solid"/>
+                      <a:round/>
+                      <a:headEnd type="none" w="med" len="med"/>
+                      <a:tailEnd type="none" w="med" len="med"/>
+                    </a:lnT>
+                    <a:lnB w="6350" cap="flat" cmpd="sng" algn="ctr">
+                      <a:solidFill>
+                        <a:srgbClr val="2A2D3E"/>
+                      </a:solidFill>
+                      <a:prstDash val="solid"/>
+                      <a:round/>
+                      <a:headEnd type="none" w="med" len="med"/>
+                      <a:tailEnd type="none" w="med" len="med"/>
+                    </a:lnB>
+                    <a:solidFill>
+                      <a:srgbClr val="1A1D2E"/>
+                    </a:solidFill>
+                  </a:tcPr>
+                </a:tc>
+                <a:tc>
+                  <a:txBody>
+                    <a:bodyPr/>
+                    <a:lstStyle/>
+                    <a:p>
+                      <a:pPr indent="0" marL="0">
+                        <a:buNone/>
+                      </a:pPr>
+                      <a:r>
+                        <a:rPr lang="en-US" sz="900" dirty="0">
+                          <a:solidFill>
+                            <a:srgbClr val="FFFFFF"/>
+                          </a:solidFill>
+                          <a:latin typeface="Arial" pitchFamily="34" charset="0"/>
+                          <a:ea typeface="Arial" pitchFamily="34" charset="-122"/>
+                          <a:cs typeface="Arial" pitchFamily="34" charset="-120"/>
+                        </a:rPr>
+                        <a:t>Tool calling</a:t>
+                      </a:r>
+                      <a:endParaRPr lang="en-US" sz="900" dirty="0">
+                        <a:latin typeface="Arial" charset="0"/>
+                        <a:ea typeface="Arial" charset="0"/>
+                        <a:cs typeface="Arial" charset="0"/>
+                      </a:endParaRPr>
+                    </a:p>
+                  </a:txBody>
+                  <a:tcPr marL="91440" marR="91440" marT="45720" marB="45720">
+                    <a:lnL w="6350" cap="flat" cmpd="sng" algn="ctr">
+                      <a:solidFill>
+                        <a:srgbClr val="2A2D3E"/>
+                      </a:solidFill>
+                      <a:prstDash val="solid"/>
+                      <a:round/>
+                      <a:headEnd type="none" w="med" len="med"/>
+                      <a:tailEnd type="none" w="med" len="med"/>
+                    </a:lnL>
+                    <a:lnR w="6350" cap="flat" cmpd="sng" algn="ctr">
+                      <a:solidFill>
+                        <a:srgbClr val="2A2D3E"/>
+                      </a:solidFill>
+                      <a:prstDash val="solid"/>
+                      <a:round/>
+                      <a:headEnd type="none" w="med" len="med"/>
+                      <a:tailEnd type="none" w="med" len="med"/>
+                    </a:lnR>
+                    <a:lnT w="6350" cap="flat" cmpd="sng" algn="ctr">
+                      <a:solidFill>
+                        <a:srgbClr val="2A2D3E"/>
+                      </a:solidFill>
+                      <a:prstDash val="solid"/>
+                      <a:round/>
+                      <a:headEnd type="none" w="med" len="med"/>
+                      <a:tailEnd type="none" w="med" len="med"/>
+                    </a:lnT>
+                    <a:lnB w="6350" cap="flat" cmpd="sng" algn="ctr">
+                      <a:solidFill>
+                        <a:srgbClr val="2A2D3E"/>
+                      </a:solidFill>
+                      <a:prstDash val="solid"/>
+                      <a:round/>
+                      <a:headEnd type="none" w="med" len="med"/>
+                      <a:tailEnd type="none" w="med" len="med"/>
+                    </a:lnB>
+                    <a:solidFill>
+                      <a:srgbClr val="1A1D2E"/>
+                    </a:solidFill>
+                  </a:tcPr>
+                </a:tc>
+              </a:tr>
+              <a:tr h="320040">
+                <a:tc>
+                  <a:txBody>
+                    <a:bodyPr/>
+                    <a:lstStyle/>
+                    <a:p>
+                      <a:pPr indent="0" marL="0">
+                        <a:buNone/>
+                      </a:pPr>
+                      <a:r>
+                        <a:rPr lang="en-US" sz="900" dirty="0">
+                          <a:solidFill>
+                            <a:srgbClr val="FFFFFF"/>
+                          </a:solidFill>
+                          <a:latin typeface="Arial" pitchFamily="34" charset="0"/>
+                          <a:ea typeface="Arial" pitchFamily="34" charset="-122"/>
+                          <a:cs typeface="Arial" pitchFamily="34" charset="-120"/>
+                        </a:rPr>
+                        <a:t>DeepSeek-R1</a:t>
+                      </a:r>
+                      <a:endParaRPr lang="en-US" sz="900" dirty="0">
+                        <a:latin typeface="Arial" charset="0"/>
+                        <a:ea typeface="Arial" charset="0"/>
+                        <a:cs typeface="Arial" charset="0"/>
+                      </a:endParaRPr>
+                    </a:p>
+                  </a:txBody>
+                  <a:tcPr marL="91440" marR="91440" marT="45720" marB="45720">
+                    <a:lnL w="6350" cap="flat" cmpd="sng" algn="ctr">
+                      <a:solidFill>
+                        <a:srgbClr val="2A2D3E"/>
+                      </a:solidFill>
+                      <a:prstDash val="solid"/>
+                      <a:round/>
+                      <a:headEnd type="none" w="med" len="med"/>
+                      <a:tailEnd type="none" w="med" len="med"/>
+                    </a:lnL>
+                    <a:lnR w="6350" cap="flat" cmpd="sng" algn="ctr">
+                      <a:solidFill>
+                        <a:srgbClr val="2A2D3E"/>
+                      </a:solidFill>
+                      <a:prstDash val="solid"/>
+                      <a:round/>
+                      <a:headEnd type="none" w="med" len="med"/>
+                      <a:tailEnd type="none" w="med" len="med"/>
+                    </a:lnR>
+                    <a:lnT w="6350" cap="flat" cmpd="sng" algn="ctr">
+                      <a:solidFill>
+                        <a:srgbClr val="2A2D3E"/>
+                      </a:solidFill>
+                      <a:prstDash val="solid"/>
+                      <a:round/>
+                      <a:headEnd type="none" w="med" len="med"/>
+                      <a:tailEnd type="none" w="med" len="med"/>
+                    </a:lnT>
+                    <a:lnB w="6350" cap="flat" cmpd="sng" algn="ctr">
+                      <a:solidFill>
+                        <a:srgbClr val="2A2D3E"/>
+                      </a:solidFill>
+                      <a:prstDash val="solid"/>
+                      <a:round/>
+                      <a:headEnd type="none" w="med" len="med"/>
+                      <a:tailEnd type="none" w="med" len="med"/>
+                    </a:lnB>
+                    <a:solidFill>
+                      <a:srgbClr val="1A1D2E"/>
+                    </a:solidFill>
+                  </a:tcPr>
+                </a:tc>
+                <a:tc>
+                  <a:txBody>
+                    <a:bodyPr/>
+                    <a:lstStyle/>
+                    <a:p>
+                      <a:pPr indent="0" marL="0">
+                        <a:buNone/>
+                      </a:pPr>
+                      <a:r>
+                        <a:rPr lang="en-US" sz="900" dirty="0">
+                          <a:solidFill>
+                            <a:srgbClr val="FFFFFF"/>
+                          </a:solidFill>
+                          <a:latin typeface="Arial" pitchFamily="34" charset="0"/>
+                          <a:ea typeface="Arial" pitchFamily="34" charset="-122"/>
+                          <a:cs typeface="Arial" pitchFamily="34" charset="-120"/>
+                        </a:rPr>
+                        <a:t>deepseek-ai/DeepSeek-R1-0528</a:t>
+                      </a:r>
+                      <a:endParaRPr lang="en-US" sz="900" dirty="0">
+                        <a:latin typeface="Arial" charset="0"/>
+                        <a:ea typeface="Arial" charset="0"/>
+                        <a:cs typeface="Arial" charset="0"/>
+                      </a:endParaRPr>
+                    </a:p>
+                  </a:txBody>
+                  <a:tcPr marL="91440" marR="91440" marT="45720" marB="45720">
+                    <a:lnL w="6350" cap="flat" cmpd="sng" algn="ctr">
+                      <a:solidFill>
+                        <a:srgbClr val="2A2D3E"/>
+                      </a:solidFill>
+                      <a:prstDash val="solid"/>
+                      <a:round/>
+                      <a:headEnd type="none" w="med" len="med"/>
+                      <a:tailEnd type="none" w="med" len="med"/>
+                    </a:lnL>
+                    <a:lnR w="6350" cap="flat" cmpd="sng" algn="ctr">
+                      <a:solidFill>
+                        <a:srgbClr val="2A2D3E"/>
+                      </a:solidFill>
+                      <a:prstDash val="solid"/>
+                      <a:round/>
+                      <a:headEnd type="none" w="med" len="med"/>
+                      <a:tailEnd type="none" w="med" len="med"/>
+                    </a:lnR>
+                    <a:lnT w="6350" cap="flat" cmpd="sng" algn="ctr">
+                      <a:solidFill>
+                        <a:srgbClr val="2A2D3E"/>
+                      </a:solidFill>
+                      <a:prstDash val="solid"/>
+                      <a:round/>
+                      <a:headEnd type="none" w="med" len="med"/>
+                      <a:tailEnd type="none" w="med" len="med"/>
+                    </a:lnT>
+                    <a:lnB w="6350" cap="flat" cmpd="sng" algn="ctr">
+                      <a:solidFill>
+                        <a:srgbClr val="2A2D3E"/>
+                      </a:solidFill>
+                      <a:prstDash val="solid"/>
+                      <a:round/>
+                      <a:headEnd type="none" w="med" len="med"/>
+                      <a:tailEnd type="none" w="med" len="med"/>
+                    </a:lnB>
+                    <a:solidFill>
+                      <a:srgbClr val="1A1D2E"/>
+                    </a:solidFill>
+                  </a:tcPr>
+                </a:tc>
+                <a:tc>
+                  <a:txBody>
+                    <a:bodyPr/>
+                    <a:lstStyle/>
+                    <a:p>
+                      <a:pPr indent="0" marL="0">
+                        <a:buNone/>
+                      </a:pPr>
+                      <a:r>
+                        <a:rPr lang="en-US" sz="900" dirty="0">
+                          <a:solidFill>
+                            <a:srgbClr val="FFFFFF"/>
+                          </a:solidFill>
+                          <a:latin typeface="Arial" pitchFamily="34" charset="0"/>
+                          <a:ea typeface="Arial" pitchFamily="34" charset="-122"/>
+                          <a:cs typeface="Arial" pitchFamily="34" charset="-120"/>
+                        </a:rPr>
+                        <a:t>Medium</a:t>
+                      </a:r>
+                      <a:endParaRPr lang="en-US" sz="900" dirty="0">
+                        <a:latin typeface="Arial" charset="0"/>
+                        <a:ea typeface="Arial" charset="0"/>
+                        <a:cs typeface="Arial" charset="0"/>
+                      </a:endParaRPr>
+                    </a:p>
+                  </a:txBody>
+                  <a:tcPr marL="91440" marR="91440" marT="45720" marB="45720">
+                    <a:lnL w="6350" cap="flat" cmpd="sng" algn="ctr">
+                      <a:solidFill>
+                        <a:srgbClr val="2A2D3E"/>
+                      </a:solidFill>
+                      <a:prstDash val="solid"/>
+                      <a:round/>
+                      <a:headEnd type="none" w="med" len="med"/>
+                      <a:tailEnd type="none" w="med" len="med"/>
+                    </a:lnL>
+                    <a:lnR w="6350" cap="flat" cmpd="sng" algn="ctr">
+                      <a:solidFill>
+                        <a:srgbClr val="2A2D3E"/>
+                      </a:solidFill>
+                      <a:prstDash val="solid"/>
+                      <a:round/>
+                      <a:headEnd type="none" w="med" len="med"/>
+                      <a:tailEnd type="none" w="med" len="med"/>
+                    </a:lnR>
+                    <a:lnT w="6350" cap="flat" cmpd="sng" algn="ctr">
+                      <a:solidFill>
+                        <a:srgbClr val="2A2D3E"/>
+                      </a:solidFill>
+                      <a:prstDash val="solid"/>
+                      <a:round/>
+                      <a:headEnd type="none" w="med" len="med"/>
+                      <a:tailEnd type="none" w="med" len="med"/>
+                    </a:lnT>
+                    <a:lnB w="6350" cap="flat" cmpd="sng" algn="ctr">
+                      <a:solidFill>
+                        <a:srgbClr val="2A2D3E"/>
+                      </a:solidFill>
+                      <a:prstDash val="solid"/>
+                      <a:round/>
+                      <a:headEnd type="none" w="med" len="med"/>
+                      <a:tailEnd type="none" w="med" len="med"/>
+                    </a:lnB>
+                    <a:solidFill>
+                      <a:srgbClr val="1A1D2E"/>
+                    </a:solidFill>
+                  </a:tcPr>
+                </a:tc>
+                <a:tc>
+                  <a:txBody>
+                    <a:bodyPr/>
+                    <a:lstStyle/>
+                    <a:p>
+                      <a:pPr indent="0" marL="0">
+                        <a:buNone/>
+                      </a:pPr>
+                      <a:r>
+                        <a:rPr lang="en-US" sz="900" dirty="0">
+                          <a:solidFill>
+                            <a:srgbClr val="FFFFFF"/>
+                          </a:solidFill>
+                          <a:latin typeface="Arial" pitchFamily="34" charset="0"/>
+                          <a:ea typeface="Arial" pitchFamily="34" charset="-122"/>
+                          <a:cs typeface="Arial" pitchFamily="34" charset="-120"/>
+                        </a:rPr>
+                        <a:t>Reasoning</a:t>
                       </a:r>
                       <a:endParaRPr lang="en-US" sz="900" dirty="0">
                         <a:latin typeface="Arial" charset="0"/>
@@ -4151,7 +4699,7 @@
                           <a:ea typeface="Arial" pitchFamily="34" charset="-122"/>
                           <a:cs typeface="Arial" pitchFamily="34" charset="-120"/>
                         </a:rPr>
-                        <a:t>Very Fast</a:t>
+                        <a:t>zai-org/GLM-5</a:t>
                       </a:r>
                       <a:endParaRPr lang="en-US" sz="900" dirty="0">
                         <a:latin typeface="Arial" charset="0"/>
@@ -4219,7 +4767,7 @@
                           <a:ea typeface="Arial" pitchFamily="34" charset="-122"/>
                           <a:cs typeface="Arial" pitchFamily="34" charset="-120"/>
                         </a:rPr>
-                        <a:t>Good</a:t>
+                        <a:t>Very Fast</a:t>
                       </a:r>
                       <a:endParaRPr lang="en-US" sz="900" dirty="0">
                         <a:latin typeface="Arial" charset="0"/>
@@ -4357,7 +4905,7 @@
                           <a:ea typeface="Arial" pitchFamily="34" charset="-122"/>
                           <a:cs typeface="Arial" pitchFamily="34" charset="-120"/>
                         </a:rPr>
-                        <a:t>DeepSeek-R1</a:t>
+                        <a:t>Qwen3</a:t>
                       </a:r>
                       <a:endParaRPr lang="en-US" sz="900" dirty="0">
                         <a:latin typeface="Arial" charset="0"/>
@@ -4425,213 +4973,7 @@
                           <a:ea typeface="Arial" pitchFamily="34" charset="-122"/>
                           <a:cs typeface="Arial" pitchFamily="34" charset="-120"/>
                         </a:rPr>
-                        <a:t>Medium</a:t>
-                      </a:r>
-                      <a:endParaRPr lang="en-US" sz="900" dirty="0">
-                        <a:latin typeface="Arial" charset="0"/>
-                        <a:ea typeface="Arial" charset="0"/>
-                        <a:cs typeface="Arial" charset="0"/>
-                      </a:endParaRPr>
-                    </a:p>
-                  </a:txBody>
-                  <a:tcPr marL="91440" marR="91440" marT="45720" marB="45720">
-                    <a:lnL w="6350" cap="flat" cmpd="sng" algn="ctr">
-                      <a:solidFill>
-                        <a:srgbClr val="2A2D3E"/>
-                      </a:solidFill>
-                      <a:prstDash val="solid"/>
-                      <a:round/>
-                      <a:headEnd type="none" w="med" len="med"/>
-                      <a:tailEnd type="none" w="med" len="med"/>
-                    </a:lnL>
-                    <a:lnR w="6350" cap="flat" cmpd="sng" algn="ctr">
-                      <a:solidFill>
-                        <a:srgbClr val="2A2D3E"/>
-                      </a:solidFill>
-                      <a:prstDash val="solid"/>
-                      <a:round/>
-                      <a:headEnd type="none" w="med" len="med"/>
-                      <a:tailEnd type="none" w="med" len="med"/>
-                    </a:lnR>
-                    <a:lnT w="6350" cap="flat" cmpd="sng" algn="ctr">
-                      <a:solidFill>
-                        <a:srgbClr val="2A2D3E"/>
-                      </a:solidFill>
-                      <a:prstDash val="solid"/>
-                      <a:round/>
-                      <a:headEnd type="none" w="med" len="med"/>
-                      <a:tailEnd type="none" w="med" len="med"/>
-                    </a:lnT>
-                    <a:lnB w="6350" cap="flat" cmpd="sng" algn="ctr">
-                      <a:solidFill>
-                        <a:srgbClr val="2A2D3E"/>
-                      </a:solidFill>
-                      <a:prstDash val="solid"/>
-                      <a:round/>
-                      <a:headEnd type="none" w="med" len="med"/>
-                      <a:tailEnd type="none" w="med" len="med"/>
-                    </a:lnB>
-                    <a:solidFill>
-                      <a:srgbClr val="1A1D2E"/>
-                    </a:solidFill>
-                  </a:tcPr>
-                </a:tc>
-                <a:tc>
-                  <a:txBody>
-                    <a:bodyPr/>
-                    <a:lstStyle/>
-                    <a:p>
-                      <a:pPr indent="0" marL="0">
-                        <a:buNone/>
-                      </a:pPr>
-                      <a:r>
-                        <a:rPr lang="en-US" sz="900" dirty="0">
-                          <a:solidFill>
-                            <a:srgbClr val="FFFFFF"/>
-                          </a:solidFill>
-                          <a:latin typeface="Arial" pitchFamily="34" charset="0"/>
-                          <a:ea typeface="Arial" pitchFamily="34" charset="-122"/>
-                          <a:cs typeface="Arial" pitchFamily="34" charset="-120"/>
-                        </a:rPr>
-                        <a:t>Very High</a:t>
-                      </a:r>
-                      <a:endParaRPr lang="en-US" sz="900" dirty="0">
-                        <a:latin typeface="Arial" charset="0"/>
-                        <a:ea typeface="Arial" charset="0"/>
-                        <a:cs typeface="Arial" charset="0"/>
-                      </a:endParaRPr>
-                    </a:p>
-                  </a:txBody>
-                  <a:tcPr marL="91440" marR="91440" marT="45720" marB="45720">
-                    <a:lnL w="6350" cap="flat" cmpd="sng" algn="ctr">
-                      <a:solidFill>
-                        <a:srgbClr val="2A2D3E"/>
-                      </a:solidFill>
-                      <a:prstDash val="solid"/>
-                      <a:round/>
-                      <a:headEnd type="none" w="med" len="med"/>
-                      <a:tailEnd type="none" w="med" len="med"/>
-                    </a:lnL>
-                    <a:lnR w="6350" cap="flat" cmpd="sng" algn="ctr">
-                      <a:solidFill>
-                        <a:srgbClr val="2A2D3E"/>
-                      </a:solidFill>
-                      <a:prstDash val="solid"/>
-                      <a:round/>
-                      <a:headEnd type="none" w="med" len="med"/>
-                      <a:tailEnd type="none" w="med" len="med"/>
-                    </a:lnR>
-                    <a:lnT w="6350" cap="flat" cmpd="sng" algn="ctr">
-                      <a:solidFill>
-                        <a:srgbClr val="2A2D3E"/>
-                      </a:solidFill>
-                      <a:prstDash val="solid"/>
-                      <a:round/>
-                      <a:headEnd type="none" w="med" len="med"/>
-                      <a:tailEnd type="none" w="med" len="med"/>
-                    </a:lnT>
-                    <a:lnB w="6350" cap="flat" cmpd="sng" algn="ctr">
-                      <a:solidFill>
-                        <a:srgbClr val="2A2D3E"/>
-                      </a:solidFill>
-                      <a:prstDash val="solid"/>
-                      <a:round/>
-                      <a:headEnd type="none" w="med" len="med"/>
-                      <a:tailEnd type="none" w="med" len="med"/>
-                    </a:lnB>
-                    <a:solidFill>
-                      <a:srgbClr val="1A1D2E"/>
-                    </a:solidFill>
-                  </a:tcPr>
-                </a:tc>
-                <a:tc>
-                  <a:txBody>
-                    <a:bodyPr/>
-                    <a:lstStyle/>
-                    <a:p>
-                      <a:pPr indent="0" marL="0">
-                        <a:buNone/>
-                      </a:pPr>
-                      <a:r>
-                        <a:rPr lang="en-US" sz="900" dirty="0">
-                          <a:solidFill>
-                            <a:srgbClr val="FFFFFF"/>
-                          </a:solidFill>
-                          <a:latin typeface="Arial" pitchFamily="34" charset="0"/>
-                          <a:ea typeface="Arial" pitchFamily="34" charset="-122"/>
-                          <a:cs typeface="Arial" pitchFamily="34" charset="-120"/>
-                        </a:rPr>
-                        <a:t>Reasoning, complex chains</a:t>
-                      </a:r>
-                      <a:endParaRPr lang="en-US" sz="900" dirty="0">
-                        <a:latin typeface="Arial" charset="0"/>
-                        <a:ea typeface="Arial" charset="0"/>
-                        <a:cs typeface="Arial" charset="0"/>
-                      </a:endParaRPr>
-                    </a:p>
-                  </a:txBody>
-                  <a:tcPr marL="91440" marR="91440" marT="45720" marB="45720">
-                    <a:lnL w="6350" cap="flat" cmpd="sng" algn="ctr">
-                      <a:solidFill>
-                        <a:srgbClr val="2A2D3E"/>
-                      </a:solidFill>
-                      <a:prstDash val="solid"/>
-                      <a:round/>
-                      <a:headEnd type="none" w="med" len="med"/>
-                      <a:tailEnd type="none" w="med" len="med"/>
-                    </a:lnL>
-                    <a:lnR w="6350" cap="flat" cmpd="sng" algn="ctr">
-                      <a:solidFill>
-                        <a:srgbClr val="2A2D3E"/>
-                      </a:solidFill>
-                      <a:prstDash val="solid"/>
-                      <a:round/>
-                      <a:headEnd type="none" w="med" len="med"/>
-                      <a:tailEnd type="none" w="med" len="med"/>
-                    </a:lnR>
-                    <a:lnT w="6350" cap="flat" cmpd="sng" algn="ctr">
-                      <a:solidFill>
-                        <a:srgbClr val="2A2D3E"/>
-                      </a:solidFill>
-                      <a:prstDash val="solid"/>
-                      <a:round/>
-                      <a:headEnd type="none" w="med" len="med"/>
-                      <a:tailEnd type="none" w="med" len="med"/>
-                    </a:lnT>
-                    <a:lnB w="6350" cap="flat" cmpd="sng" algn="ctr">
-                      <a:solidFill>
-                        <a:srgbClr val="2A2D3E"/>
-                      </a:solidFill>
-                      <a:prstDash val="solid"/>
-                      <a:round/>
-                      <a:headEnd type="none" w="med" len="med"/>
-                      <a:tailEnd type="none" w="med" len="med"/>
-                    </a:lnB>
-                    <a:solidFill>
-                      <a:srgbClr val="1A1D2E"/>
-                    </a:solidFill>
-                  </a:tcPr>
-                </a:tc>
-              </a:tr>
-              <a:tr h="320040">
-                <a:tc>
-                  <a:txBody>
-                    <a:bodyPr/>
-                    <a:lstStyle/>
-                    <a:p>
-                      <a:pPr indent="0" marL="0">
-                        <a:buNone/>
-                      </a:pPr>
-                      <a:r>
-                        <a:rPr lang="en-US" sz="900" dirty="0">
-                          <a:solidFill>
-                            <a:srgbClr val="FFFFFF"/>
-                          </a:solidFill>
-                          <a:latin typeface="Arial" pitchFamily="34" charset="0"/>
-                          <a:ea typeface="Arial" pitchFamily="34" charset="-122"/>
-                          <a:cs typeface="Arial" pitchFamily="34" charset="-120"/>
-                        </a:rPr>
-                        <a:t>Qwen3.5-35B</a:t>
+                        <a:t>Qwen/Qwen3-30B-A3B</a:t>
                       </a:r>
                       <a:endParaRPr lang="en-US" sz="900" dirty="0">
                         <a:latin typeface="Arial" charset="0"/>
@@ -4767,74 +5109,6 @@
                           <a:ea typeface="Arial" pitchFamily="34" charset="-122"/>
                           <a:cs typeface="Arial" pitchFamily="34" charset="-120"/>
                         </a:rPr>
-                        <a:t>High</a:t>
-                      </a:r>
-                      <a:endParaRPr lang="en-US" sz="900" dirty="0">
-                        <a:latin typeface="Arial" charset="0"/>
-                        <a:ea typeface="Arial" charset="0"/>
-                        <a:cs typeface="Arial" charset="0"/>
-                      </a:endParaRPr>
-                    </a:p>
-                  </a:txBody>
-                  <a:tcPr marL="91440" marR="91440" marT="45720" marB="45720">
-                    <a:lnL w="6350" cap="flat" cmpd="sng" algn="ctr">
-                      <a:solidFill>
-                        <a:srgbClr val="2A2D3E"/>
-                      </a:solidFill>
-                      <a:prstDash val="solid"/>
-                      <a:round/>
-                      <a:headEnd type="none" w="med" len="med"/>
-                      <a:tailEnd type="none" w="med" len="med"/>
-                    </a:lnL>
-                    <a:lnR w="6350" cap="flat" cmpd="sng" algn="ctr">
-                      <a:solidFill>
-                        <a:srgbClr val="2A2D3E"/>
-                      </a:solidFill>
-                      <a:prstDash val="solid"/>
-                      <a:round/>
-                      <a:headEnd type="none" w="med" len="med"/>
-                      <a:tailEnd type="none" w="med" len="med"/>
-                    </a:lnR>
-                    <a:lnT w="6350" cap="flat" cmpd="sng" algn="ctr">
-                      <a:solidFill>
-                        <a:srgbClr val="2A2D3E"/>
-                      </a:solidFill>
-                      <a:prstDash val="solid"/>
-                      <a:round/>
-                      <a:headEnd type="none" w="med" len="med"/>
-                      <a:tailEnd type="none" w="med" len="med"/>
-                    </a:lnT>
-                    <a:lnB w="6350" cap="flat" cmpd="sng" algn="ctr">
-                      <a:solidFill>
-                        <a:srgbClr val="2A2D3E"/>
-                      </a:solidFill>
-                      <a:prstDash val="solid"/>
-                      <a:round/>
-                      <a:headEnd type="none" w="med" len="med"/>
-                      <a:tailEnd type="none" w="med" len="med"/>
-                    </a:lnB>
-                    <a:solidFill>
-                      <a:srgbClr val="1A1D2E"/>
-                    </a:solidFill>
-                  </a:tcPr>
-                </a:tc>
-                <a:tc>
-                  <a:txBody>
-                    <a:bodyPr/>
-                    <a:lstStyle/>
-                    <a:p>
-                      <a:pPr indent="0" marL="0">
-                        <a:buNone/>
-                      </a:pPr>
-                      <a:r>
-                        <a:rPr lang="en-US" sz="900" dirty="0">
-                          <a:solidFill>
-                            <a:srgbClr val="FFFFFF"/>
-                          </a:solidFill>
-                          <a:latin typeface="Arial" pitchFamily="34" charset="0"/>
-                          <a:ea typeface="Arial" pitchFamily="34" charset="-122"/>
-                          <a:cs typeface="Arial" pitchFamily="34" charset="-120"/>
-                        </a:rPr>
                         <a:t>Code, multilingual</a:t>
                       </a:r>
                       <a:endParaRPr lang="en-US" sz="900" dirty="0">
@@ -4887,284 +5161,116 @@
                   </a:tcPr>
                 </a:tc>
               </a:tr>
-              <a:tr h="320040">
-                <a:tc>
-                  <a:txBody>
-                    <a:bodyPr/>
-                    <a:lstStyle/>
-                    <a:p>
-                      <a:pPr indent="0" marL="0">
-                        <a:buNone/>
-                      </a:pPr>
-                      <a:r>
-                        <a:rPr lang="en-US" sz="900" dirty="0">
-                          <a:solidFill>
-                            <a:srgbClr val="FFFFFF"/>
-                          </a:solidFill>
-                          <a:latin typeface="Arial" pitchFamily="34" charset="0"/>
-                          <a:ea typeface="Arial" pitchFamily="34" charset="-122"/>
-                          <a:cs typeface="Arial" pitchFamily="34" charset="-120"/>
-                        </a:rPr>
-                        <a:t>Mistral Large</a:t>
-                      </a:r>
-                      <a:endParaRPr lang="en-US" sz="900" dirty="0">
-                        <a:latin typeface="Arial" charset="0"/>
-                        <a:ea typeface="Arial" charset="0"/>
-                        <a:cs typeface="Arial" charset="0"/>
-                      </a:endParaRPr>
-                    </a:p>
-                  </a:txBody>
-                  <a:tcPr marL="91440" marR="91440" marT="45720" marB="45720">
-                    <a:lnL w="6350" cap="flat" cmpd="sng" algn="ctr">
-                      <a:solidFill>
-                        <a:srgbClr val="2A2D3E"/>
-                      </a:solidFill>
-                      <a:prstDash val="solid"/>
-                      <a:round/>
-                      <a:headEnd type="none" w="med" len="med"/>
-                      <a:tailEnd type="none" w="med" len="med"/>
-                    </a:lnL>
-                    <a:lnR w="6350" cap="flat" cmpd="sng" algn="ctr">
-                      <a:solidFill>
-                        <a:srgbClr val="2A2D3E"/>
-                      </a:solidFill>
-                      <a:prstDash val="solid"/>
-                      <a:round/>
-                      <a:headEnd type="none" w="med" len="med"/>
-                      <a:tailEnd type="none" w="med" len="med"/>
-                    </a:lnR>
-                    <a:lnT w="6350" cap="flat" cmpd="sng" algn="ctr">
-                      <a:solidFill>
-                        <a:srgbClr val="2A2D3E"/>
-                      </a:solidFill>
-                      <a:prstDash val="solid"/>
-                      <a:round/>
-                      <a:headEnd type="none" w="med" len="med"/>
-                      <a:tailEnd type="none" w="med" len="med"/>
-                    </a:lnT>
-                    <a:lnB w="6350" cap="flat" cmpd="sng" algn="ctr">
-                      <a:solidFill>
-                        <a:srgbClr val="2A2D3E"/>
-                      </a:solidFill>
-                      <a:prstDash val="solid"/>
-                      <a:round/>
-                      <a:headEnd type="none" w="med" len="med"/>
-                      <a:tailEnd type="none" w="med" len="med"/>
-                    </a:lnB>
-                    <a:solidFill>
-                      <a:srgbClr val="1A1D2E"/>
-                    </a:solidFill>
-                  </a:tcPr>
-                </a:tc>
-                <a:tc>
-                  <a:txBody>
-                    <a:bodyPr/>
-                    <a:lstStyle/>
-                    <a:p>
-                      <a:pPr indent="0" marL="0">
-                        <a:buNone/>
-                      </a:pPr>
-                      <a:r>
-                        <a:rPr lang="en-US" sz="900" dirty="0">
-                          <a:solidFill>
-                            <a:srgbClr val="FFFFFF"/>
-                          </a:solidFill>
-                          <a:latin typeface="Arial" pitchFamily="34" charset="0"/>
-                          <a:ea typeface="Arial" pitchFamily="34" charset="-122"/>
-                          <a:cs typeface="Arial" pitchFamily="34" charset="-120"/>
-                        </a:rPr>
-                        <a:t>Fast</a:t>
-                      </a:r>
-                      <a:endParaRPr lang="en-US" sz="900" dirty="0">
-                        <a:latin typeface="Arial" charset="0"/>
-                        <a:ea typeface="Arial" charset="0"/>
-                        <a:cs typeface="Arial" charset="0"/>
-                      </a:endParaRPr>
-                    </a:p>
-                  </a:txBody>
-                  <a:tcPr marL="91440" marR="91440" marT="45720" marB="45720">
-                    <a:lnL w="6350" cap="flat" cmpd="sng" algn="ctr">
-                      <a:solidFill>
-                        <a:srgbClr val="2A2D3E"/>
-                      </a:solidFill>
-                      <a:prstDash val="solid"/>
-                      <a:round/>
-                      <a:headEnd type="none" w="med" len="med"/>
-                      <a:tailEnd type="none" w="med" len="med"/>
-                    </a:lnL>
-                    <a:lnR w="6350" cap="flat" cmpd="sng" algn="ctr">
-                      <a:solidFill>
-                        <a:srgbClr val="2A2D3E"/>
-                      </a:solidFill>
-                      <a:prstDash val="solid"/>
-                      <a:round/>
-                      <a:headEnd type="none" w="med" len="med"/>
-                      <a:tailEnd type="none" w="med" len="med"/>
-                    </a:lnR>
-                    <a:lnT w="6350" cap="flat" cmpd="sng" algn="ctr">
-                      <a:solidFill>
-                        <a:srgbClr val="2A2D3E"/>
-                      </a:solidFill>
-                      <a:prstDash val="solid"/>
-                      <a:round/>
-                      <a:headEnd type="none" w="med" len="med"/>
-                      <a:tailEnd type="none" w="med" len="med"/>
-                    </a:lnT>
-                    <a:lnB w="6350" cap="flat" cmpd="sng" algn="ctr">
-                      <a:solidFill>
-                        <a:srgbClr val="2A2D3E"/>
-                      </a:solidFill>
-                      <a:prstDash val="solid"/>
-                      <a:round/>
-                      <a:headEnd type="none" w="med" len="med"/>
-                      <a:tailEnd type="none" w="med" len="med"/>
-                    </a:lnB>
-                    <a:solidFill>
-                      <a:srgbClr val="1A1D2E"/>
-                    </a:solidFill>
-                  </a:tcPr>
-                </a:tc>
-                <a:tc>
-                  <a:txBody>
-                    <a:bodyPr/>
-                    <a:lstStyle/>
-                    <a:p>
-                      <a:pPr indent="0" marL="0">
-                        <a:buNone/>
-                      </a:pPr>
-                      <a:r>
-                        <a:rPr lang="en-US" sz="900" dirty="0">
-                          <a:solidFill>
-                            <a:srgbClr val="FFFFFF"/>
-                          </a:solidFill>
-                          <a:latin typeface="Arial" pitchFamily="34" charset="0"/>
-                          <a:ea typeface="Arial" pitchFamily="34" charset="-122"/>
-                          <a:cs typeface="Arial" pitchFamily="34" charset="-120"/>
-                        </a:rPr>
-                        <a:t>High</a:t>
-                      </a:r>
-                      <a:endParaRPr lang="en-US" sz="900" dirty="0">
-                        <a:latin typeface="Arial" charset="0"/>
-                        <a:ea typeface="Arial" charset="0"/>
-                        <a:cs typeface="Arial" charset="0"/>
-                      </a:endParaRPr>
-                    </a:p>
-                  </a:txBody>
-                  <a:tcPr marL="91440" marR="91440" marT="45720" marB="45720">
-                    <a:lnL w="6350" cap="flat" cmpd="sng" algn="ctr">
-                      <a:solidFill>
-                        <a:srgbClr val="2A2D3E"/>
-                      </a:solidFill>
-                      <a:prstDash val="solid"/>
-                      <a:round/>
-                      <a:headEnd type="none" w="med" len="med"/>
-                      <a:tailEnd type="none" w="med" len="med"/>
-                    </a:lnL>
-                    <a:lnR w="6350" cap="flat" cmpd="sng" algn="ctr">
-                      <a:solidFill>
-                        <a:srgbClr val="2A2D3E"/>
-                      </a:solidFill>
-                      <a:prstDash val="solid"/>
-                      <a:round/>
-                      <a:headEnd type="none" w="med" len="med"/>
-                      <a:tailEnd type="none" w="med" len="med"/>
-                    </a:lnR>
-                    <a:lnT w="6350" cap="flat" cmpd="sng" algn="ctr">
-                      <a:solidFill>
-                        <a:srgbClr val="2A2D3E"/>
-                      </a:solidFill>
-                      <a:prstDash val="solid"/>
-                      <a:round/>
-                      <a:headEnd type="none" w="med" len="med"/>
-                      <a:tailEnd type="none" w="med" len="med"/>
-                    </a:lnT>
-                    <a:lnB w="6350" cap="flat" cmpd="sng" algn="ctr">
-                      <a:solidFill>
-                        <a:srgbClr val="2A2D3E"/>
-                      </a:solidFill>
-                      <a:prstDash val="solid"/>
-                      <a:round/>
-                      <a:headEnd type="none" w="med" len="med"/>
-                      <a:tailEnd type="none" w="med" len="med"/>
-                    </a:lnB>
-                    <a:solidFill>
-                      <a:srgbClr val="1A1D2E"/>
-                    </a:solidFill>
-                  </a:tcPr>
-                </a:tc>
-                <a:tc>
-                  <a:txBody>
-                    <a:bodyPr/>
-                    <a:lstStyle/>
-                    <a:p>
-                      <a:pPr indent="0" marL="0">
-                        <a:buNone/>
-                      </a:pPr>
-                      <a:r>
-                        <a:rPr lang="en-US" sz="900" dirty="0">
-                          <a:solidFill>
-                            <a:srgbClr val="FFFFFF"/>
-                          </a:solidFill>
-                          <a:latin typeface="Arial" pitchFamily="34" charset="0"/>
-                          <a:ea typeface="Arial" pitchFamily="34" charset="-122"/>
-                          <a:cs typeface="Arial" pitchFamily="34" charset="-120"/>
-                        </a:rPr>
-                        <a:t>European languages</a:t>
-                      </a:r>
-                      <a:endParaRPr lang="en-US" sz="900" dirty="0">
-                        <a:latin typeface="Arial" charset="0"/>
-                        <a:ea typeface="Arial" charset="0"/>
-                        <a:cs typeface="Arial" charset="0"/>
-                      </a:endParaRPr>
-                    </a:p>
-                  </a:txBody>
-                  <a:tcPr marL="91440" marR="91440" marT="45720" marB="45720">
-                    <a:lnL w="6350" cap="flat" cmpd="sng" algn="ctr">
-                      <a:solidFill>
-                        <a:srgbClr val="2A2D3E"/>
-                      </a:solidFill>
-                      <a:prstDash val="solid"/>
-                      <a:round/>
-                      <a:headEnd type="none" w="med" len="med"/>
-                      <a:tailEnd type="none" w="med" len="med"/>
-                    </a:lnL>
-                    <a:lnR w="6350" cap="flat" cmpd="sng" algn="ctr">
-                      <a:solidFill>
-                        <a:srgbClr val="2A2D3E"/>
-                      </a:solidFill>
-                      <a:prstDash val="solid"/>
-                      <a:round/>
-                      <a:headEnd type="none" w="med" len="med"/>
-                      <a:tailEnd type="none" w="med" len="med"/>
-                    </a:lnR>
-                    <a:lnT w="6350" cap="flat" cmpd="sng" algn="ctr">
-                      <a:solidFill>
-                        <a:srgbClr val="2A2D3E"/>
-                      </a:solidFill>
-                      <a:prstDash val="solid"/>
-                      <a:round/>
-                      <a:headEnd type="none" w="med" len="med"/>
-                      <a:tailEnd type="none" w="med" len="med"/>
-                    </a:lnT>
-                    <a:lnB w="6350" cap="flat" cmpd="sng" algn="ctr">
-                      <a:solidFill>
-                        <a:srgbClr val="2A2D3E"/>
-                      </a:solidFill>
-                      <a:prstDash val="solid"/>
-                      <a:round/>
-                      <a:headEnd type="none" w="med" len="med"/>
-                      <a:tailEnd type="none" w="med" len="med"/>
-                    </a:lnB>
-                    <a:solidFill>
-                      <a:srgbClr val="1A1D2E"/>
-                    </a:solidFill>
-                  </a:tcPr>
-                </a:tc>
-              </a:tr>
             </a:tbl>
           </a:graphicData>
         </a:graphic>
       </p:graphicFrame>
+      <p:sp>
+        <p:nvSpPr>
+          <p:cNvPr id="7" name="Text 4"/>
+          <p:cNvSpPr/>
+          <p:nvPr/>
+        </p:nvSpPr>
+        <p:spPr>
+          <a:xfrm>
+            <a:off x="731520" y="3474720"/>
+            <a:ext cx="2743200" cy="274320"/>
+          </a:xfrm>
+          <a:prstGeom prst="rect">
+            <a:avLst/>
+          </a:prstGeom>
+          <a:noFill/>
+          <a:ln/>
+        </p:spPr>
+        <p:txBody>
+          <a:bodyPr wrap="square" rtlCol="0" anchor="ctr"/>
+          <a:lstStyle/>
+          <a:p>
+            <a:pPr indent="0" marL="0">
+              <a:buNone/>
+            </a:pPr>
+            <a:r>
+              <a:rPr lang="en-US" sz="1200" dirty="0">
+                <a:solidFill>
+                  <a:srgbClr val="9CA3AF"/>
+                </a:solidFill>
+                <a:latin typeface="Arial" pitchFamily="34" charset="0"/>
+                <a:ea typeface="Arial" pitchFamily="34" charset="-122"/>
+                <a:cs typeface="Arial" pitchFamily="34" charset="-120"/>
+              </a:rPr>
+              <a:t>Switch anytime:</a:t>
+            </a:r>
+            <a:endParaRPr lang="en-US" sz="1200" dirty="0"/>
+          </a:p>
+        </p:txBody>
+      </p:sp>
+      <p:sp>
+        <p:nvSpPr>
+          <p:cNvPr id="8" name="Shape 5"/>
+          <p:cNvSpPr/>
+          <p:nvPr/>
+        </p:nvSpPr>
+        <p:spPr>
+          <a:xfrm>
+            <a:off x="731520" y="3840480"/>
+            <a:ext cx="7680960" cy="411480"/>
+          </a:xfrm>
+          <a:prstGeom prst="roundRect">
+            <a:avLst>
+              <a:gd name="adj" fmla="val 17778"/>
+            </a:avLst>
+          </a:prstGeom>
+          <a:solidFill>
+            <a:srgbClr val="161927"/>
+          </a:solidFill>
+          <a:ln/>
+        </p:spPr>
+      </p:sp>
+      <p:sp>
+        <p:nvSpPr>
+          <p:cNvPr id="9" name="Text 6"/>
+          <p:cNvSpPr/>
+          <p:nvPr/>
+        </p:nvSpPr>
+        <p:spPr>
+          <a:xfrm>
+            <a:off x="868680" y="3913632"/>
+            <a:ext cx="7406640" cy="265176"/>
+          </a:xfrm>
+          <a:prstGeom prst="rect">
+            <a:avLst/>
+          </a:prstGeom>
+          <a:noFill/>
+          <a:ln/>
+        </p:spPr>
+        <p:txBody>
+          <a:bodyPr wrap="square" rtlCol="0" anchor="t"/>
+          <a:lstStyle/>
+          <a:p>
+            <a:pPr indent="0" marL="0">
+              <a:spcBef>
+                <a:spcPts val="200"/>
+              </a:spcBef>
+              <a:spcAft>
+                <a:spcPts val="200"/>
+              </a:spcAft>
+              <a:buNone/>
+            </a:pPr>
+            <a:r>
+              <a:rPr lang="en-US" sz="1000" dirty="0">
+                <a:solidFill>
+                  <a:srgbClr val="B8FF4A"/>
+                </a:solidFill>
+                <a:latin typeface="Courier New" pitchFamily="34" charset="0"/>
+                <a:ea typeface="Courier New" pitchFamily="34" charset="-122"/>
+                <a:cs typeface="Courier New" pitchFamily="34" charset="-120"/>
+              </a:rPr>
+              <a:t>/model kimi    # or /model llama70b, /model deepseek</a:t>
+            </a:r>
+            <a:endParaRPr lang="en-US" sz="1000" dirty="0"/>
+          </a:p>
+        </p:txBody>
+      </p:sp>
     </p:spTree>
   </p:cSld>
   <p:clrMapOvr>
@@ -5810,7 +5916,30 @@
                 <a:ea typeface="Courier New" pitchFamily="34" charset="-122"/>
                 <a:cs typeface="Courier New" pitchFamily="34" charset="-120"/>
               </a:rPr>
-              <a:t>  --custom-base-url "https://api.tokenfactory.nebius.com/v1" \</a:t>
+              <a:t>  --custom-base-url "https://api.tokenfactory.nebius.com/v1/" \</a:t>
+            </a:r>
+            <a:endParaRPr lang="en-US" sz="900" dirty="0"/>
+          </a:p>
+          <a:p>
+            <a:pPr indent="0" marL="0">
+              <a:spcBef>
+                <a:spcPts val="200"/>
+              </a:spcBef>
+              <a:spcAft>
+                <a:spcPts val="200"/>
+              </a:spcAft>
+              <a:buNone/>
+            </a:pPr>
+            <a:r>
+              <a:rPr lang="en-US" sz="900" dirty="0">
+                <a:solidFill>
+                  <a:srgbClr val="B8FF4A"/>
+                </a:solidFill>
+                <a:latin typeface="Courier New" pitchFamily="34" charset="0"/>
+                <a:ea typeface="Courier New" pitchFamily="34" charset="-122"/>
+                <a:cs typeface="Courier New" pitchFamily="34" charset="-120"/>
+              </a:rPr>
+              <a:t>  --custom-model-id "moonshotai/Kimi-K2.5" \</a:t>
             </a:r>
             <a:endParaRPr lang="en-US" sz="900" dirty="0"/>
           </a:p>
@@ -6285,7 +6414,7 @@
                 <a:ea typeface="Arial" pitchFamily="34" charset="-122"/>
                 <a:cs typeface="Arial" pitchFamily="34" charset="-120"/>
               </a:rPr>
-              <a:t>Token Factory supports JSON mode natively.</a:t>
+              <a:t>Works with Kimi K2.5, Llama 3.3, and DeepSeek-R1.</a:t>
             </a:r>
             <a:endParaRPr lang="en-US" sz="1400" dirty="0"/>
           </a:p>
@@ -6703,7 +6832,7 @@
                 <a:ea typeface="Arial" pitchFamily="34" charset="-122"/>
                 <a:cs typeface="Arial" pitchFamily="34" charset="-120"/>
               </a:rPr>
-              <a:t>Auto-scales to zero. Spins up on demand. No VM management.</a:t>
+              <a:t>Auto-scales to zero. Spins up on demand.</a:t>
             </a:r>
             <a:endParaRPr lang="en-US" sz="1400" dirty="0"/>
           </a:p>
@@ -8311,7 +8440,7 @@
                 <a:ea typeface="Arial" pitchFamily="34" charset="-122"/>
                 <a:cs typeface="Arial" pitchFamily="34" charset="-120"/>
               </a:rPr>
-              <a:t>Bind to loopback in dev, 0.0.0.0 behind proxy in prod</a:t>
+              <a:t>Bind to loopback in dev, 0.0.0.0 behind proxy</a:t>
             </a:r>
             <a:endParaRPr lang="en-US" sz="1400" dirty="0"/>
           </a:p>
@@ -9510,7 +9639,7 @@
                           <a:ea typeface="Arial" pitchFamily="34" charset="-122"/>
                           <a:cs typeface="Arial" pitchFamily="34" charset="-120"/>
                         </a:rPr>
-                        <a:t>/model glm5</a:t>
+                        <a:t>/model kimi</a:t>
                       </a:r>
                       <a:endParaRPr lang="en-US" sz="900" dirty="0">
                         <a:latin typeface="Arial" charset="0"/>
@@ -10523,7 +10652,7 @@
                           <a:ea typeface="Arial" pitchFamily="34" charset="-122"/>
                           <a:cs typeface="Arial" pitchFamily="34" charset="-120"/>
                         </a:rPr>
-                        <a:t>Token Factory</a:t>
+                        <a:t>Token Factory Docs</a:t>
                       </a:r>
                       <a:endParaRPr lang="en-US" sz="900" dirty="0">
                         <a:latin typeface="Arial" charset="0"/>
@@ -10591,7 +10720,145 @@
                           <a:ea typeface="Arial" pitchFamily="34" charset="-122"/>
                           <a:cs typeface="Arial" pitchFamily="34" charset="-120"/>
                         </a:rPr>
-                        <a:t>console.nebius.com</a:t>
+                        <a:t>docs.tokenfactory.nebius.com</a:t>
+                      </a:r>
+                      <a:endParaRPr lang="en-US" sz="900" dirty="0">
+                        <a:latin typeface="Arial" charset="0"/>
+                        <a:ea typeface="Arial" charset="0"/>
+                        <a:cs typeface="Arial" charset="0"/>
+                      </a:endParaRPr>
+                    </a:p>
+                  </a:txBody>
+                  <a:tcPr marL="91440" marR="91440" marT="45720" marB="45720">
+                    <a:lnL w="6350" cap="flat" cmpd="sng" algn="ctr">
+                      <a:solidFill>
+                        <a:srgbClr val="2A2D3E"/>
+                      </a:solidFill>
+                      <a:prstDash val="solid"/>
+                      <a:round/>
+                      <a:headEnd type="none" w="med" len="med"/>
+                      <a:tailEnd type="none" w="med" len="med"/>
+                    </a:lnL>
+                    <a:lnR w="6350" cap="flat" cmpd="sng" algn="ctr">
+                      <a:solidFill>
+                        <a:srgbClr val="2A2D3E"/>
+                      </a:solidFill>
+                      <a:prstDash val="solid"/>
+                      <a:round/>
+                      <a:headEnd type="none" w="med" len="med"/>
+                      <a:tailEnd type="none" w="med" len="med"/>
+                    </a:lnR>
+                    <a:lnT w="6350" cap="flat" cmpd="sng" algn="ctr">
+                      <a:solidFill>
+                        <a:srgbClr val="2A2D3E"/>
+                      </a:solidFill>
+                      <a:prstDash val="solid"/>
+                      <a:round/>
+                      <a:headEnd type="none" w="med" len="med"/>
+                      <a:tailEnd type="none" w="med" len="med"/>
+                    </a:lnT>
+                    <a:lnB w="6350" cap="flat" cmpd="sng" algn="ctr">
+                      <a:solidFill>
+                        <a:srgbClr val="2A2D3E"/>
+                      </a:solidFill>
+                      <a:prstDash val="solid"/>
+                      <a:round/>
+                      <a:headEnd type="none" w="med" len="med"/>
+                      <a:tailEnd type="none" w="med" len="med"/>
+                    </a:lnB>
+                    <a:solidFill>
+                      <a:srgbClr val="1A1D2E"/>
+                    </a:solidFill>
+                  </a:tcPr>
+                </a:tc>
+              </a:tr>
+              <a:tr h="320040">
+                <a:tc>
+                  <a:txBody>
+                    <a:bodyPr/>
+                    <a:lstStyle/>
+                    <a:p>
+                      <a:pPr indent="0" marL="0">
+                        <a:buNone/>
+                      </a:pPr>
+                      <a:r>
+                        <a:rPr lang="en-US" sz="900" dirty="0">
+                          <a:solidFill>
+                            <a:srgbClr val="FFFFFF"/>
+                          </a:solidFill>
+                          <a:latin typeface="Arial" pitchFamily="34" charset="0"/>
+                          <a:ea typeface="Arial" pitchFamily="34" charset="-122"/>
+                          <a:cs typeface="Arial" pitchFamily="34" charset="-120"/>
+                        </a:rPr>
+                        <a:t>Cookbook Repo</a:t>
+                      </a:r>
+                      <a:endParaRPr lang="en-US" sz="900" dirty="0">
+                        <a:latin typeface="Arial" charset="0"/>
+                        <a:ea typeface="Arial" charset="0"/>
+                        <a:cs typeface="Arial" charset="0"/>
+                      </a:endParaRPr>
+                    </a:p>
+                  </a:txBody>
+                  <a:tcPr marL="91440" marR="91440" marT="45720" marB="45720">
+                    <a:lnL w="6350" cap="flat" cmpd="sng" algn="ctr">
+                      <a:solidFill>
+                        <a:srgbClr val="2A2D3E"/>
+                      </a:solidFill>
+                      <a:prstDash val="solid"/>
+                      <a:round/>
+                      <a:headEnd type="none" w="med" len="med"/>
+                      <a:tailEnd type="none" w="med" len="med"/>
+                    </a:lnL>
+                    <a:lnR w="6350" cap="flat" cmpd="sng" algn="ctr">
+                      <a:solidFill>
+                        <a:srgbClr val="2A2D3E"/>
+                      </a:solidFill>
+                      <a:prstDash val="solid"/>
+                      <a:round/>
+                      <a:headEnd type="none" w="med" len="med"/>
+                      <a:tailEnd type="none" w="med" len="med"/>
+                    </a:lnR>
+                    <a:lnT w="6350" cap="flat" cmpd="sng" algn="ctr">
+                      <a:solidFill>
+                        <a:srgbClr val="2A2D3E"/>
+                      </a:solidFill>
+                      <a:prstDash val="solid"/>
+                      <a:round/>
+                      <a:headEnd type="none" w="med" len="med"/>
+                      <a:tailEnd type="none" w="med" len="med"/>
+                    </a:lnT>
+                    <a:lnB w="6350" cap="flat" cmpd="sng" algn="ctr">
+                      <a:solidFill>
+                        <a:srgbClr val="2A2D3E"/>
+                      </a:solidFill>
+                      <a:prstDash val="solid"/>
+                      <a:round/>
+                      <a:headEnd type="none" w="med" len="med"/>
+                      <a:tailEnd type="none" w="med" len="med"/>
+                    </a:lnB>
+                    <a:solidFill>
+                      <a:srgbClr val="1A1D2E"/>
+                    </a:solidFill>
+                  </a:tcPr>
+                </a:tc>
+                <a:tc>
+                  <a:txBody>
+                    <a:bodyPr/>
+                    <a:lstStyle/>
+                    <a:p>
+                      <a:pPr indent="0" marL="0">
+                        <a:buNone/>
+                      </a:pPr>
+                      <a:r>
+                        <a:rPr lang="en-US" sz="900" dirty="0">
+                          <a:solidFill>
+                            <a:srgbClr val="FFFFFF"/>
+                          </a:solidFill>
+                          <a:latin typeface="Arial" pitchFamily="34" charset="0"/>
+                          <a:ea typeface="Arial" pitchFamily="34" charset="-122"/>
+                          <a:cs typeface="Arial" pitchFamily="34" charset="-120"/>
+                        </a:rPr>
+                        <a:t>github.com/nebius/token-factory-cookbook</a:t>
                       </a:r>
                       <a:endParaRPr lang="en-US" sz="900" dirty="0">
                         <a:latin typeface="Arial" charset="0"/>
@@ -12356,7 +12623,7 @@
                 <a:ea typeface="Arial" pitchFamily="34" charset="-122"/>
                 <a:cs typeface="Arial" pitchFamily="34" charset="-120"/>
               </a:rPr>
-              <a:t>You don't need to use Claude or OpenAI.</a:t>
+              <a:t>You don't need Claude or OpenAI.</a:t>
             </a:r>
             <a:endParaRPr lang="en-US" sz="1600" dirty="0"/>
           </a:p>
@@ -12681,7 +12948,7 @@
                           <a:ea typeface="Arial" pitchFamily="34" charset="-122"/>
                           <a:cs typeface="Arial" pitchFamily="34" charset="-120"/>
                         </a:rPr>
-                        <a:t>Llama 3.1 70B, GLM-5, DeepSeek-R1</a:t>
+                        <a:t>Kimi K2.5, Llama 3.3 70B, DeepSeek-R1</a:t>
                       </a:r>
                       <a:endParaRPr lang="en-US" sz="900" dirty="0">
                         <a:latin typeface="Arial" charset="0"/>
@@ -14336,45 +14603,6 @@
           </a:graphicData>
         </a:graphic>
       </p:graphicFrame>
-      <p:sp>
-        <p:nvSpPr>
-          <p:cNvPr id="7" name="Text 4"/>
-          <p:cNvSpPr/>
-          <p:nvPr/>
-        </p:nvSpPr>
-        <p:spPr>
-          <a:xfrm>
-            <a:off x="731520" y="3474720"/>
-            <a:ext cx="7315200" cy="365760"/>
-          </a:xfrm>
-          <a:prstGeom prst="rect">
-            <a:avLst/>
-          </a:prstGeom>
-          <a:noFill/>
-          <a:ln/>
-        </p:spPr>
-        <p:txBody>
-          <a:bodyPr wrap="square" rtlCol="0" anchor="ctr"/>
-          <a:lstStyle/>
-          <a:p>
-            <a:pPr indent="0" marL="0">
-              <a:buNone/>
-            </a:pPr>
-            <a:r>
-              <a:rPr lang="en-US" sz="1400" b="1" dirty="0">
-                <a:solidFill>
-                  <a:srgbClr val="FFFFFF"/>
-                </a:solidFill>
-                <a:latin typeface="Arial" pitchFamily="34" charset="0"/>
-                <a:ea typeface="Arial" pitchFamily="34" charset="-122"/>
-                <a:cs typeface="Arial" pitchFamily="34" charset="-120"/>
-              </a:rPr>
-              <a:t>We'll start with npm (fastest), then show Docker and Serverless.</a:t>
-            </a:r>
-            <a:endParaRPr lang="en-US" sz="1400" dirty="0"/>
-          </a:p>
-        </p:txBody>
-      </p:sp>
     </p:spTree>
   </p:cSld>
   <p:clrMapOvr>
@@ -15592,7 +15820,7 @@
                 <a:ea typeface="Courier New" pitchFamily="34" charset="-122"/>
                 <a:cs typeface="Courier New" pitchFamily="34" charset="-120"/>
               </a:rPr>
-              <a:t>        baseUrl: "https://api.tokenfactory.nebius.com/v1",</a:t>
+              <a:t>        baseUrl: "https://api.tokenfactory.nebius.com/v1/",</a:t>
             </a:r>
             <a:endParaRPr lang="en-US" sz="800" dirty="0"/>
           </a:p>
@@ -15684,7 +15912,7 @@
                 <a:ea typeface="Courier New" pitchFamily="34" charset="-122"/>
                 <a:cs typeface="Courier New" pitchFamily="34" charset="-120"/>
               </a:rPr>
-              <a:t>          { id: "meta-llama/Meta-Llama-3.1-70B-Instruct",</a:t>
+              <a:t>          { id: "moonshotai/Kimi-K2.5",</a:t>
             </a:r>
             <a:endParaRPr lang="en-US" sz="800" dirty="0"/>
           </a:p>
@@ -15707,7 +15935,7 @@
                 <a:ea typeface="Courier New" pitchFamily="34" charset="-122"/>
                 <a:cs typeface="Courier New" pitchFamily="34" charset="-120"/>
               </a:rPr>
-              <a:t>            name: "Llama 3.1 70B", contextWindow: 128000 },</a:t>
+              <a:t>            name: "Kimi K2.5", contextWindow: 128000 },</a:t>
             </a:r>
             <a:endParaRPr lang="en-US" sz="800" dirty="0"/>
           </a:p>
@@ -15730,7 +15958,7 @@
                 <a:ea typeface="Courier New" pitchFamily="34" charset="-122"/>
                 <a:cs typeface="Courier New" pitchFamily="34" charset="-120"/>
               </a:rPr>
-              <a:t>          { id: "zai-org/GLM-5",</a:t>
+              <a:t>          { id: "meta-llama/Llama-3.3-70B-Instruct-fast",</a:t>
             </a:r>
             <a:endParaRPr lang="en-US" sz="800" dirty="0"/>
           </a:p>
@@ -15753,7 +15981,7 @@
                 <a:ea typeface="Courier New" pitchFamily="34" charset="-122"/>
                 <a:cs typeface="Courier New" pitchFamily="34" charset="-120"/>
               </a:rPr>
-              <a:t>            name: "GLM-5", contextWindow: 128000 },</a:t>
+              <a:t>            name: "Llama 3.3 70B", contextWindow: 128000 },</a:t>
             </a:r>
             <a:endParaRPr lang="en-US" sz="800" dirty="0"/>
           </a:p>
@@ -15776,7 +16004,7 @@
                 <a:ea typeface="Courier New" pitchFamily="34" charset="-122"/>
                 <a:cs typeface="Courier New" pitchFamily="34" charset="-120"/>
               </a:rPr>
-              <a:t>          { id: "deepseek-ai/DeepSeek-R1",</a:t>
+              <a:t>          { id: "deepseek-ai/DeepSeek-R1-0528",</a:t>
             </a:r>
             <a:endParaRPr lang="en-US" sz="800" dirty="0"/>
           </a:p>
@@ -15937,7 +16165,7 @@
                 <a:ea typeface="Courier New" pitchFamily="34" charset="-122"/>
                 <a:cs typeface="Courier New" pitchFamily="34" charset="-120"/>
               </a:rPr>
-              <a:t>    model: { primary: "nebius/meta-llama/..." },</a:t>
+              <a:t>    model: { primary: "nebius/moonshotai/Kimi-K2.5" },</a:t>
             </a:r>
             <a:endParaRPr lang="en-US" sz="800" dirty="0"/>
           </a:p>
@@ -15983,7 +16211,7 @@
                 <a:ea typeface="Courier New" pitchFamily="34" charset="-122"/>
                 <a:cs typeface="Courier New" pitchFamily="34" charset="-120"/>
               </a:rPr>
-              <a:t>      "nebius/.../Llama-3.1-70B": { alias: "llama70b" },</a:t>
+              <a:t>      "nebius/moonshotai/Kimi-K2.5": { alias: "kimi" },</a:t>
             </a:r>
             <a:endParaRPr lang="en-US" sz="800" dirty="0"/>
           </a:p>
@@ -16006,7 +16234,7 @@
                 <a:ea typeface="Courier New" pitchFamily="34" charset="-122"/>
                 <a:cs typeface="Courier New" pitchFamily="34" charset="-120"/>
               </a:rPr>
-              <a:t>      "nebius/zai-org/GLM-5": { alias: "glm5" },</a:t>
+              <a:t>      "nebius/.../Llama-3.3-70B": { alias: "llama70b" },</a:t>
             </a:r>
             <a:endParaRPr lang="en-US" sz="800" dirty="0"/>
           </a:p>
@@ -16029,7 +16257,7 @@
                 <a:ea typeface="Courier New" pitchFamily="34" charset="-122"/>
                 <a:cs typeface="Courier New" pitchFamily="34" charset="-120"/>
               </a:rPr>
-              <a:t>      "nebius/.../DeepSeek-R1": { alias: "deepseek" }</a:t>
+              <a:t>      "nebius/.../DeepSeek-R1-0528": { alias: "deepseek" }</a:t>
             </a:r>
             <a:endParaRPr lang="en-US" sz="800" dirty="0"/>
           </a:p>

</xml_diff>